<commit_message>
infra: verify approved AWS cleanup and preserve lifecycle evidence
</commit_message>
<xml_diff>
--- a/docs/presentation/eventsProject-Tache-AWS-EKS.pptx
+++ b/docs/presentation/eventsProject-Tache-AWS-EKS.pptx
@@ -5,7 +5,7 @@
     <p:sldMasterId id="2147483648" r:id="rId1"/>
   </p:sldMasterIdLst>
   <p:notesMasterIdLst>
-    <p:notesMasterId r:id="rId35"/>
+    <p:notesMasterId r:id="rId36"/>
   </p:notesMasterIdLst>
   <p:sldIdLst>
     <p:sldId id="256" r:id="rId2"/>
@@ -41,6 +41,7 @@
     <p:sldId id="286" r:id="rId32"/>
     <p:sldId id="287" r:id="rId33"/>
     <p:sldId id="288" r:id="rId34"/>
+    <p:sldId id="289" r:id="rId35"/>
   </p:sldIdLst>
   <p:sldSz cx="12192000" cy="6858000"/>
   <p:notesSz cx="6858000" cy="9144000"/>
@@ -222,7 +223,7 @@
             </a:lvl1pPr>
           </a:lstStyle>
           <a:p>
-            <a:fld id="{4AFC1A98-A037-479F-8D47-859999B6D0D4}" type="datetimeFigureOut">
+            <a:fld id="{3F0D11A2-71F2-4DF7-8388-33B7A17027F5}" type="datetimeFigureOut">
               <a:rPr lang="en-US" smtClean="0"/>
               <a:t>10/29/2026</a:t>
             </a:fld>
@@ -381,7 +382,7 @@
             </a:lvl1pPr>
           </a:lstStyle>
           <a:p>
-            <a:fld id="{0FCF8F27-596B-4576-8FC0-45CAC942679A}" type="slidenum">
+            <a:fld id="{AEAAFB2C-D2FA-4015-8580-9D15DAF0315E}" type="slidenum">
               <a:rPr lang="en-US" smtClean="0"/>
               <a:t>‹#›</a:t>
             </a:fld>
@@ -392,7 +393,7 @@
     </p:spTree>
     <p:extLst>
       <p:ext uri="{BB962C8B-B14F-4D97-AF65-F5344CB8AC3E}">
-        <p14:creationId xmlns:p14="http://schemas.microsoft.com/office/powerpoint/2010/main" val="1977864063"/>
+        <p14:creationId xmlns:p14="http://schemas.microsoft.com/office/powerpoint/2010/main" val="2915947419"/>
       </p:ext>
     </p:extLst>
   </p:cSld>
@@ -555,7 +556,7 @@
           <a:bodyPr/>
           <a:lstStyle/>
           <a:p>
-            <a:fld id="{0FCF8F27-596B-4576-8FC0-45CAC942679A}" type="slidenum">
+            <a:fld id="{AEAAFB2C-D2FA-4015-8580-9D15DAF0315E}" type="slidenum">
               <a:rPr lang="en-US" smtClean="0"/>
               <a:t>1</a:t>
             </a:fld>
@@ -566,7 +567,7 @@
     </p:spTree>
     <p:extLst>
       <p:ext uri="{BB962C8B-B14F-4D97-AF65-F5344CB8AC3E}">
-        <p14:creationId xmlns:p14="http://schemas.microsoft.com/office/powerpoint/2010/main" val="1710158402"/>
+        <p14:creationId xmlns:p14="http://schemas.microsoft.com/office/powerpoint/2010/main" val="2350875408"/>
       </p:ext>
     </p:extLst>
   </p:cSld>
@@ -639,7 +640,7 @@
           <a:bodyPr/>
           <a:lstStyle/>
           <a:p>
-            <a:fld id="{0FCF8F27-596B-4576-8FC0-45CAC942679A}" type="slidenum">
+            <a:fld id="{AEAAFB2C-D2FA-4015-8580-9D15DAF0315E}" type="slidenum">
               <a:rPr lang="en-US" smtClean="0"/>
               <a:t>10</a:t>
             </a:fld>
@@ -650,7 +651,7 @@
     </p:spTree>
     <p:extLst>
       <p:ext uri="{BB962C8B-B14F-4D97-AF65-F5344CB8AC3E}">
-        <p14:creationId xmlns:p14="http://schemas.microsoft.com/office/powerpoint/2010/main" val="3700433757"/>
+        <p14:creationId xmlns:p14="http://schemas.microsoft.com/office/powerpoint/2010/main" val="3186780929"/>
       </p:ext>
     </p:extLst>
   </p:cSld>
@@ -723,7 +724,7 @@
           <a:bodyPr/>
           <a:lstStyle/>
           <a:p>
-            <a:fld id="{0FCF8F27-596B-4576-8FC0-45CAC942679A}" type="slidenum">
+            <a:fld id="{AEAAFB2C-D2FA-4015-8580-9D15DAF0315E}" type="slidenum">
               <a:rPr lang="en-US" smtClean="0"/>
               <a:t>11</a:t>
             </a:fld>
@@ -734,7 +735,7 @@
     </p:spTree>
     <p:extLst>
       <p:ext uri="{BB962C8B-B14F-4D97-AF65-F5344CB8AC3E}">
-        <p14:creationId xmlns:p14="http://schemas.microsoft.com/office/powerpoint/2010/main" val="996574139"/>
+        <p14:creationId xmlns:p14="http://schemas.microsoft.com/office/powerpoint/2010/main" val="3193838656"/>
       </p:ext>
     </p:extLst>
   </p:cSld>
@@ -807,7 +808,7 @@
           <a:bodyPr/>
           <a:lstStyle/>
           <a:p>
-            <a:fld id="{0FCF8F27-596B-4576-8FC0-45CAC942679A}" type="slidenum">
+            <a:fld id="{AEAAFB2C-D2FA-4015-8580-9D15DAF0315E}" type="slidenum">
               <a:rPr lang="en-US" smtClean="0"/>
               <a:t>12</a:t>
             </a:fld>
@@ -818,7 +819,7 @@
     </p:spTree>
     <p:extLst>
       <p:ext uri="{BB962C8B-B14F-4D97-AF65-F5344CB8AC3E}">
-        <p14:creationId xmlns:p14="http://schemas.microsoft.com/office/powerpoint/2010/main" val="555153004"/>
+        <p14:creationId xmlns:p14="http://schemas.microsoft.com/office/powerpoint/2010/main" val="4275250135"/>
       </p:ext>
     </p:extLst>
   </p:cSld>
@@ -891,7 +892,7 @@
           <a:bodyPr/>
           <a:lstStyle/>
           <a:p>
-            <a:fld id="{0FCF8F27-596B-4576-8FC0-45CAC942679A}" type="slidenum">
+            <a:fld id="{AEAAFB2C-D2FA-4015-8580-9D15DAF0315E}" type="slidenum">
               <a:rPr lang="en-US" smtClean="0"/>
               <a:t>13</a:t>
             </a:fld>
@@ -902,7 +903,7 @@
     </p:spTree>
     <p:extLst>
       <p:ext uri="{BB962C8B-B14F-4D97-AF65-F5344CB8AC3E}">
-        <p14:creationId xmlns:p14="http://schemas.microsoft.com/office/powerpoint/2010/main" val="932697609"/>
+        <p14:creationId xmlns:p14="http://schemas.microsoft.com/office/powerpoint/2010/main" val="44575450"/>
       </p:ext>
     </p:extLst>
   </p:cSld>
@@ -975,7 +976,7 @@
           <a:bodyPr/>
           <a:lstStyle/>
           <a:p>
-            <a:fld id="{0FCF8F27-596B-4576-8FC0-45CAC942679A}" type="slidenum">
+            <a:fld id="{AEAAFB2C-D2FA-4015-8580-9D15DAF0315E}" type="slidenum">
               <a:rPr lang="en-US" smtClean="0"/>
               <a:t>14</a:t>
             </a:fld>
@@ -986,7 +987,7 @@
     </p:spTree>
     <p:extLst>
       <p:ext uri="{BB962C8B-B14F-4D97-AF65-F5344CB8AC3E}">
-        <p14:creationId xmlns:p14="http://schemas.microsoft.com/office/powerpoint/2010/main" val="4214626339"/>
+        <p14:creationId xmlns:p14="http://schemas.microsoft.com/office/powerpoint/2010/main" val="428976745"/>
       </p:ext>
     </p:extLst>
   </p:cSld>
@@ -1059,7 +1060,7 @@
           <a:bodyPr/>
           <a:lstStyle/>
           <a:p>
-            <a:fld id="{0FCF8F27-596B-4576-8FC0-45CAC942679A}" type="slidenum">
+            <a:fld id="{AEAAFB2C-D2FA-4015-8580-9D15DAF0315E}" type="slidenum">
               <a:rPr lang="en-US" smtClean="0"/>
               <a:t>15</a:t>
             </a:fld>
@@ -1070,7 +1071,7 @@
     </p:spTree>
     <p:extLst>
       <p:ext uri="{BB962C8B-B14F-4D97-AF65-F5344CB8AC3E}">
-        <p14:creationId xmlns:p14="http://schemas.microsoft.com/office/powerpoint/2010/main" val="3770094437"/>
+        <p14:creationId xmlns:p14="http://schemas.microsoft.com/office/powerpoint/2010/main" val="1582648563"/>
       </p:ext>
     </p:extLst>
   </p:cSld>
@@ -1143,7 +1144,7 @@
           <a:bodyPr/>
           <a:lstStyle/>
           <a:p>
-            <a:fld id="{0FCF8F27-596B-4576-8FC0-45CAC942679A}" type="slidenum">
+            <a:fld id="{AEAAFB2C-D2FA-4015-8580-9D15DAF0315E}" type="slidenum">
               <a:rPr lang="en-US" smtClean="0"/>
               <a:t>16</a:t>
             </a:fld>
@@ -1154,7 +1155,7 @@
     </p:spTree>
     <p:extLst>
       <p:ext uri="{BB962C8B-B14F-4D97-AF65-F5344CB8AC3E}">
-        <p14:creationId xmlns:p14="http://schemas.microsoft.com/office/powerpoint/2010/main" val="2980392756"/>
+        <p14:creationId xmlns:p14="http://schemas.microsoft.com/office/powerpoint/2010/main" val="1294482175"/>
       </p:ext>
     </p:extLst>
   </p:cSld>
@@ -1227,7 +1228,7 @@
           <a:bodyPr/>
           <a:lstStyle/>
           <a:p>
-            <a:fld id="{0FCF8F27-596B-4576-8FC0-45CAC942679A}" type="slidenum">
+            <a:fld id="{AEAAFB2C-D2FA-4015-8580-9D15DAF0315E}" type="slidenum">
               <a:rPr lang="en-US" smtClean="0"/>
               <a:t>17</a:t>
             </a:fld>
@@ -1238,7 +1239,7 @@
     </p:spTree>
     <p:extLst>
       <p:ext uri="{BB962C8B-B14F-4D97-AF65-F5344CB8AC3E}">
-        <p14:creationId xmlns:p14="http://schemas.microsoft.com/office/powerpoint/2010/main" val="3631447659"/>
+        <p14:creationId xmlns:p14="http://schemas.microsoft.com/office/powerpoint/2010/main" val="702848260"/>
       </p:ext>
     </p:extLst>
   </p:cSld>
@@ -1311,7 +1312,7 @@
           <a:bodyPr/>
           <a:lstStyle/>
           <a:p>
-            <a:fld id="{0FCF8F27-596B-4576-8FC0-45CAC942679A}" type="slidenum">
+            <a:fld id="{AEAAFB2C-D2FA-4015-8580-9D15DAF0315E}" type="slidenum">
               <a:rPr lang="en-US" smtClean="0"/>
               <a:t>18</a:t>
             </a:fld>
@@ -1322,7 +1323,7 @@
     </p:spTree>
     <p:extLst>
       <p:ext uri="{BB962C8B-B14F-4D97-AF65-F5344CB8AC3E}">
-        <p14:creationId xmlns:p14="http://schemas.microsoft.com/office/powerpoint/2010/main" val="2990737859"/>
+        <p14:creationId xmlns:p14="http://schemas.microsoft.com/office/powerpoint/2010/main" val="1915951778"/>
       </p:ext>
     </p:extLst>
   </p:cSld>
@@ -1395,7 +1396,7 @@
           <a:bodyPr/>
           <a:lstStyle/>
           <a:p>
-            <a:fld id="{0FCF8F27-596B-4576-8FC0-45CAC942679A}" type="slidenum">
+            <a:fld id="{AEAAFB2C-D2FA-4015-8580-9D15DAF0315E}" type="slidenum">
               <a:rPr lang="en-US" smtClean="0"/>
               <a:t>19</a:t>
             </a:fld>
@@ -1406,7 +1407,7 @@
     </p:spTree>
     <p:extLst>
       <p:ext uri="{BB962C8B-B14F-4D97-AF65-F5344CB8AC3E}">
-        <p14:creationId xmlns:p14="http://schemas.microsoft.com/office/powerpoint/2010/main" val="2633746853"/>
+        <p14:creationId xmlns:p14="http://schemas.microsoft.com/office/powerpoint/2010/main" val="1004065095"/>
       </p:ext>
     </p:extLst>
   </p:cSld>
@@ -1479,7 +1480,7 @@
           <a:bodyPr/>
           <a:lstStyle/>
           <a:p>
-            <a:fld id="{0FCF8F27-596B-4576-8FC0-45CAC942679A}" type="slidenum">
+            <a:fld id="{AEAAFB2C-D2FA-4015-8580-9D15DAF0315E}" type="slidenum">
               <a:rPr lang="en-US" smtClean="0"/>
               <a:t>2</a:t>
             </a:fld>
@@ -1490,7 +1491,7 @@
     </p:spTree>
     <p:extLst>
       <p:ext uri="{BB962C8B-B14F-4D97-AF65-F5344CB8AC3E}">
-        <p14:creationId xmlns:p14="http://schemas.microsoft.com/office/powerpoint/2010/main" val="3602596597"/>
+        <p14:creationId xmlns:p14="http://schemas.microsoft.com/office/powerpoint/2010/main" val="2170607229"/>
       </p:ext>
     </p:extLst>
   </p:cSld>
@@ -1563,7 +1564,7 @@
           <a:bodyPr/>
           <a:lstStyle/>
           <a:p>
-            <a:fld id="{0FCF8F27-596B-4576-8FC0-45CAC942679A}" type="slidenum">
+            <a:fld id="{AEAAFB2C-D2FA-4015-8580-9D15DAF0315E}" type="slidenum">
               <a:rPr lang="en-US" smtClean="0"/>
               <a:t>20</a:t>
             </a:fld>
@@ -1574,7 +1575,7 @@
     </p:spTree>
     <p:extLst>
       <p:ext uri="{BB962C8B-B14F-4D97-AF65-F5344CB8AC3E}">
-        <p14:creationId xmlns:p14="http://schemas.microsoft.com/office/powerpoint/2010/main" val="3427016408"/>
+        <p14:creationId xmlns:p14="http://schemas.microsoft.com/office/powerpoint/2010/main" val="3388730694"/>
       </p:ext>
     </p:extLst>
   </p:cSld>
@@ -1647,7 +1648,7 @@
           <a:bodyPr/>
           <a:lstStyle/>
           <a:p>
-            <a:fld id="{0FCF8F27-596B-4576-8FC0-45CAC942679A}" type="slidenum">
+            <a:fld id="{AEAAFB2C-D2FA-4015-8580-9D15DAF0315E}" type="slidenum">
               <a:rPr lang="en-US" smtClean="0"/>
               <a:t>21</a:t>
             </a:fld>
@@ -1658,7 +1659,7 @@
     </p:spTree>
     <p:extLst>
       <p:ext uri="{BB962C8B-B14F-4D97-AF65-F5344CB8AC3E}">
-        <p14:creationId xmlns:p14="http://schemas.microsoft.com/office/powerpoint/2010/main" val="202035247"/>
+        <p14:creationId xmlns:p14="http://schemas.microsoft.com/office/powerpoint/2010/main" val="505977794"/>
       </p:ext>
     </p:extLst>
   </p:cSld>
@@ -1731,7 +1732,7 @@
           <a:bodyPr/>
           <a:lstStyle/>
           <a:p>
-            <a:fld id="{0FCF8F27-596B-4576-8FC0-45CAC942679A}" type="slidenum">
+            <a:fld id="{AEAAFB2C-D2FA-4015-8580-9D15DAF0315E}" type="slidenum">
               <a:rPr lang="en-US" smtClean="0"/>
               <a:t>22</a:t>
             </a:fld>
@@ -1742,7 +1743,7 @@
     </p:spTree>
     <p:extLst>
       <p:ext uri="{BB962C8B-B14F-4D97-AF65-F5344CB8AC3E}">
-        <p14:creationId xmlns:p14="http://schemas.microsoft.com/office/powerpoint/2010/main" val="4070667594"/>
+        <p14:creationId xmlns:p14="http://schemas.microsoft.com/office/powerpoint/2010/main" val="3022955822"/>
       </p:ext>
     </p:extLst>
   </p:cSld>
@@ -1815,7 +1816,7 @@
           <a:bodyPr/>
           <a:lstStyle/>
           <a:p>
-            <a:fld id="{0FCF8F27-596B-4576-8FC0-45CAC942679A}" type="slidenum">
+            <a:fld id="{AEAAFB2C-D2FA-4015-8580-9D15DAF0315E}" type="slidenum">
               <a:rPr lang="en-US" smtClean="0"/>
               <a:t>23</a:t>
             </a:fld>
@@ -1826,7 +1827,7 @@
     </p:spTree>
     <p:extLst>
       <p:ext uri="{BB962C8B-B14F-4D97-AF65-F5344CB8AC3E}">
-        <p14:creationId xmlns:p14="http://schemas.microsoft.com/office/powerpoint/2010/main" val="3870791514"/>
+        <p14:creationId xmlns:p14="http://schemas.microsoft.com/office/powerpoint/2010/main" val="845837406"/>
       </p:ext>
     </p:extLst>
   </p:cSld>
@@ -1899,7 +1900,7 @@
           <a:bodyPr/>
           <a:lstStyle/>
           <a:p>
-            <a:fld id="{0FCF8F27-596B-4576-8FC0-45CAC942679A}" type="slidenum">
+            <a:fld id="{AEAAFB2C-D2FA-4015-8580-9D15DAF0315E}" type="slidenum">
               <a:rPr lang="en-US" smtClean="0"/>
               <a:t>24</a:t>
             </a:fld>
@@ -1910,7 +1911,7 @@
     </p:spTree>
     <p:extLst>
       <p:ext uri="{BB962C8B-B14F-4D97-AF65-F5344CB8AC3E}">
-        <p14:creationId xmlns:p14="http://schemas.microsoft.com/office/powerpoint/2010/main" val="1485361486"/>
+        <p14:creationId xmlns:p14="http://schemas.microsoft.com/office/powerpoint/2010/main" val="1787824959"/>
       </p:ext>
     </p:extLst>
   </p:cSld>
@@ -1983,7 +1984,7 @@
           <a:bodyPr/>
           <a:lstStyle/>
           <a:p>
-            <a:fld id="{0FCF8F27-596B-4576-8FC0-45CAC942679A}" type="slidenum">
+            <a:fld id="{AEAAFB2C-D2FA-4015-8580-9D15DAF0315E}" type="slidenum">
               <a:rPr lang="en-US" smtClean="0"/>
               <a:t>25</a:t>
             </a:fld>
@@ -1994,7 +1995,7 @@
     </p:spTree>
     <p:extLst>
       <p:ext uri="{BB962C8B-B14F-4D97-AF65-F5344CB8AC3E}">
-        <p14:creationId xmlns:p14="http://schemas.microsoft.com/office/powerpoint/2010/main" val="1873920995"/>
+        <p14:creationId xmlns:p14="http://schemas.microsoft.com/office/powerpoint/2010/main" val="231875030"/>
       </p:ext>
     </p:extLst>
   </p:cSld>
@@ -2067,7 +2068,7 @@
           <a:bodyPr/>
           <a:lstStyle/>
           <a:p>
-            <a:fld id="{0FCF8F27-596B-4576-8FC0-45CAC942679A}" type="slidenum">
+            <a:fld id="{AEAAFB2C-D2FA-4015-8580-9D15DAF0315E}" type="slidenum">
               <a:rPr lang="en-US" smtClean="0"/>
               <a:t>26</a:t>
             </a:fld>
@@ -2078,7 +2079,7 @@
     </p:spTree>
     <p:extLst>
       <p:ext uri="{BB962C8B-B14F-4D97-AF65-F5344CB8AC3E}">
-        <p14:creationId xmlns:p14="http://schemas.microsoft.com/office/powerpoint/2010/main" val="3658403577"/>
+        <p14:creationId xmlns:p14="http://schemas.microsoft.com/office/powerpoint/2010/main" val="556261454"/>
       </p:ext>
     </p:extLst>
   </p:cSld>
@@ -2151,7 +2152,7 @@
           <a:bodyPr/>
           <a:lstStyle/>
           <a:p>
-            <a:fld id="{0FCF8F27-596B-4576-8FC0-45CAC942679A}" type="slidenum">
+            <a:fld id="{AEAAFB2C-D2FA-4015-8580-9D15DAF0315E}" type="slidenum">
               <a:rPr lang="en-US" smtClean="0"/>
               <a:t>27</a:t>
             </a:fld>
@@ -2162,7 +2163,7 @@
     </p:spTree>
     <p:extLst>
       <p:ext uri="{BB962C8B-B14F-4D97-AF65-F5344CB8AC3E}">
-        <p14:creationId xmlns:p14="http://schemas.microsoft.com/office/powerpoint/2010/main" val="1230339079"/>
+        <p14:creationId xmlns:p14="http://schemas.microsoft.com/office/powerpoint/2010/main" val="3721006875"/>
       </p:ext>
     </p:extLst>
   </p:cSld>
@@ -2235,7 +2236,7 @@
           <a:bodyPr/>
           <a:lstStyle/>
           <a:p>
-            <a:fld id="{0FCF8F27-596B-4576-8FC0-45CAC942679A}" type="slidenum">
+            <a:fld id="{AEAAFB2C-D2FA-4015-8580-9D15DAF0315E}" type="slidenum">
               <a:rPr lang="en-US" smtClean="0"/>
               <a:t>28</a:t>
             </a:fld>
@@ -2246,7 +2247,7 @@
     </p:spTree>
     <p:extLst>
       <p:ext uri="{BB962C8B-B14F-4D97-AF65-F5344CB8AC3E}">
-        <p14:creationId xmlns:p14="http://schemas.microsoft.com/office/powerpoint/2010/main" val="3328855908"/>
+        <p14:creationId xmlns:p14="http://schemas.microsoft.com/office/powerpoint/2010/main" val="2542800939"/>
       </p:ext>
     </p:extLst>
   </p:cSld>
@@ -2319,7 +2320,7 @@
           <a:bodyPr/>
           <a:lstStyle/>
           <a:p>
-            <a:fld id="{0FCF8F27-596B-4576-8FC0-45CAC942679A}" type="slidenum">
+            <a:fld id="{AEAAFB2C-D2FA-4015-8580-9D15DAF0315E}" type="slidenum">
               <a:rPr lang="en-US" smtClean="0"/>
               <a:t>29</a:t>
             </a:fld>
@@ -2330,7 +2331,7 @@
     </p:spTree>
     <p:extLst>
       <p:ext uri="{BB962C8B-B14F-4D97-AF65-F5344CB8AC3E}">
-        <p14:creationId xmlns:p14="http://schemas.microsoft.com/office/powerpoint/2010/main" val="1657183664"/>
+        <p14:creationId xmlns:p14="http://schemas.microsoft.com/office/powerpoint/2010/main" val="1574856419"/>
       </p:ext>
     </p:extLst>
   </p:cSld>
@@ -2403,7 +2404,7 @@
           <a:bodyPr/>
           <a:lstStyle/>
           <a:p>
-            <a:fld id="{0FCF8F27-596B-4576-8FC0-45CAC942679A}" type="slidenum">
+            <a:fld id="{AEAAFB2C-D2FA-4015-8580-9D15DAF0315E}" type="slidenum">
               <a:rPr lang="en-US" smtClean="0"/>
               <a:t>3</a:t>
             </a:fld>
@@ -2414,7 +2415,7 @@
     </p:spTree>
     <p:extLst>
       <p:ext uri="{BB962C8B-B14F-4D97-AF65-F5344CB8AC3E}">
-        <p14:creationId xmlns:p14="http://schemas.microsoft.com/office/powerpoint/2010/main" val="1811905949"/>
+        <p14:creationId xmlns:p14="http://schemas.microsoft.com/office/powerpoint/2010/main" val="3613460712"/>
       </p:ext>
     </p:extLst>
   </p:cSld>
@@ -2487,7 +2488,7 @@
           <a:bodyPr/>
           <a:lstStyle/>
           <a:p>
-            <a:fld id="{0FCF8F27-596B-4576-8FC0-45CAC942679A}" type="slidenum">
+            <a:fld id="{AEAAFB2C-D2FA-4015-8580-9D15DAF0315E}" type="slidenum">
               <a:rPr lang="en-US" smtClean="0"/>
               <a:t>30</a:t>
             </a:fld>
@@ -2498,7 +2499,7 @@
     </p:spTree>
     <p:extLst>
       <p:ext uri="{BB962C8B-B14F-4D97-AF65-F5344CB8AC3E}">
-        <p14:creationId xmlns:p14="http://schemas.microsoft.com/office/powerpoint/2010/main" val="4134371287"/>
+        <p14:creationId xmlns:p14="http://schemas.microsoft.com/office/powerpoint/2010/main" val="4066703575"/>
       </p:ext>
     </p:extLst>
   </p:cSld>
@@ -2571,7 +2572,7 @@
           <a:bodyPr/>
           <a:lstStyle/>
           <a:p>
-            <a:fld id="{0FCF8F27-596B-4576-8FC0-45CAC942679A}" type="slidenum">
+            <a:fld id="{AEAAFB2C-D2FA-4015-8580-9D15DAF0315E}" type="slidenum">
               <a:rPr lang="en-US" smtClean="0"/>
               <a:t>31</a:t>
             </a:fld>
@@ -2582,7 +2583,7 @@
     </p:spTree>
     <p:extLst>
       <p:ext uri="{BB962C8B-B14F-4D97-AF65-F5344CB8AC3E}">
-        <p14:creationId xmlns:p14="http://schemas.microsoft.com/office/powerpoint/2010/main" val="3869870088"/>
+        <p14:creationId xmlns:p14="http://schemas.microsoft.com/office/powerpoint/2010/main" val="2695357073"/>
       </p:ext>
     </p:extLst>
   </p:cSld>
@@ -2655,7 +2656,7 @@
           <a:bodyPr/>
           <a:lstStyle/>
           <a:p>
-            <a:fld id="{0FCF8F27-596B-4576-8FC0-45CAC942679A}" type="slidenum">
+            <a:fld id="{AEAAFB2C-D2FA-4015-8580-9D15DAF0315E}" type="slidenum">
               <a:rPr lang="en-US" smtClean="0"/>
               <a:t>32</a:t>
             </a:fld>
@@ -2666,7 +2667,7 @@
     </p:spTree>
     <p:extLst>
       <p:ext uri="{BB962C8B-B14F-4D97-AF65-F5344CB8AC3E}">
-        <p14:creationId xmlns:p14="http://schemas.microsoft.com/office/powerpoint/2010/main" val="2266639418"/>
+        <p14:creationId xmlns:p14="http://schemas.microsoft.com/office/powerpoint/2010/main" val="2778446144"/>
       </p:ext>
     </p:extLst>
   </p:cSld>
@@ -2739,7 +2740,7 @@
           <a:bodyPr/>
           <a:lstStyle/>
           <a:p>
-            <a:fld id="{0FCF8F27-596B-4576-8FC0-45CAC942679A}" type="slidenum">
+            <a:fld id="{AEAAFB2C-D2FA-4015-8580-9D15DAF0315E}" type="slidenum">
               <a:rPr lang="en-US" smtClean="0"/>
               <a:t>33</a:t>
             </a:fld>
@@ -2750,7 +2751,91 @@
     </p:spTree>
     <p:extLst>
       <p:ext uri="{BB962C8B-B14F-4D97-AF65-F5344CB8AC3E}">
-        <p14:creationId xmlns:p14="http://schemas.microsoft.com/office/powerpoint/2010/main" val="613166837"/>
+        <p14:creationId xmlns:p14="http://schemas.microsoft.com/office/powerpoint/2010/main" val="690711034"/>
+      </p:ext>
+    </p:extLst>
+  </p:cSld>
+  <p:clrMapOvr>
+    <a:masterClrMapping/>
+  </p:clrMapOvr>
+</p:notes>
+</file>
+
+<file path=ppt/notesSlides/notesSlide34.xml><?xml version="1.0" encoding="utf-8"?>
+<p:notes xmlns:a="http://schemas.openxmlformats.org/drawingml/2006/main" xmlns:r="http://schemas.openxmlformats.org/officeDocument/2006/relationships" xmlns:p="http://schemas.openxmlformats.org/presentationml/2006/main">
+  <p:cSld>
+    <p:spTree>
+      <p:nvGrpSpPr>
+        <p:cNvPr id="1" name=""/>
+        <p:cNvGrpSpPr/>
+        <p:nvPr/>
+      </p:nvGrpSpPr>
+      <p:grpSpPr>
+        <a:xfrm>
+          <a:off x="0" y="0"/>
+          <a:ext cx="0" cy="0"/>
+          <a:chOff x="0" y="0"/>
+          <a:chExt cx="0" cy="0"/>
+        </a:xfrm>
+      </p:grpSpPr>
+      <p:sp>
+        <p:nvSpPr>
+          <p:cNvPr id="2" name="Slide Image Placeholder 1"/>
+          <p:cNvSpPr>
+            <a:spLocks noGrp="1" noRot="1" noChangeAspect="1"/>
+          </p:cNvSpPr>
+          <p:nvPr>
+            <p:ph type="sldImg"/>
+          </p:nvPr>
+        </p:nvSpPr>
+        <p:spPr/>
+      </p:sp>
+      <p:sp>
+        <p:nvSpPr>
+          <p:cNvPr id="3" name="Notes Placeholder 2"/>
+          <p:cNvSpPr>
+            <a:spLocks noGrp="1"/>
+          </p:cNvSpPr>
+          <p:nvPr>
+            <p:ph type="body" idx="1"/>
+          </p:nvPr>
+        </p:nvSpPr>
+        <p:spPr/>
+        <p:txBody>
+          <a:bodyPr/>
+          <a:lstStyle/>
+          <a:p>
+            <a:endParaRPr lang="en-US"/>
+          </a:p>
+        </p:txBody>
+      </p:sp>
+      <p:sp>
+        <p:nvSpPr>
+          <p:cNvPr id="4" name="Slide Number Placeholder 3"/>
+          <p:cNvSpPr>
+            <a:spLocks noGrp="1"/>
+          </p:cNvSpPr>
+          <p:nvPr>
+            <p:ph type="sldNum" sz="quarter" idx="10"/>
+          </p:nvPr>
+        </p:nvSpPr>
+        <p:spPr/>
+        <p:txBody>
+          <a:bodyPr/>
+          <a:lstStyle/>
+          <a:p>
+            <a:fld id="{AEAAFB2C-D2FA-4015-8580-9D15DAF0315E}" type="slidenum">
+              <a:rPr lang="en-US" smtClean="0"/>
+              <a:t>34</a:t>
+            </a:fld>
+            <a:endParaRPr lang="en-US"/>
+          </a:p>
+        </p:txBody>
+      </p:sp>
+    </p:spTree>
+    <p:extLst>
+      <p:ext uri="{BB962C8B-B14F-4D97-AF65-F5344CB8AC3E}">
+        <p14:creationId xmlns:p14="http://schemas.microsoft.com/office/powerpoint/2010/main" val="2576571606"/>
       </p:ext>
     </p:extLst>
   </p:cSld>
@@ -2823,7 +2908,7 @@
           <a:bodyPr/>
           <a:lstStyle/>
           <a:p>
-            <a:fld id="{0FCF8F27-596B-4576-8FC0-45CAC942679A}" type="slidenum">
+            <a:fld id="{AEAAFB2C-D2FA-4015-8580-9D15DAF0315E}" type="slidenum">
               <a:rPr lang="en-US" smtClean="0"/>
               <a:t>4</a:t>
             </a:fld>
@@ -2834,7 +2919,7 @@
     </p:spTree>
     <p:extLst>
       <p:ext uri="{BB962C8B-B14F-4D97-AF65-F5344CB8AC3E}">
-        <p14:creationId xmlns:p14="http://schemas.microsoft.com/office/powerpoint/2010/main" val="1246779645"/>
+        <p14:creationId xmlns:p14="http://schemas.microsoft.com/office/powerpoint/2010/main" val="3708418357"/>
       </p:ext>
     </p:extLst>
   </p:cSld>
@@ -2907,7 +2992,7 @@
           <a:bodyPr/>
           <a:lstStyle/>
           <a:p>
-            <a:fld id="{0FCF8F27-596B-4576-8FC0-45CAC942679A}" type="slidenum">
+            <a:fld id="{AEAAFB2C-D2FA-4015-8580-9D15DAF0315E}" type="slidenum">
               <a:rPr lang="en-US" smtClean="0"/>
               <a:t>5</a:t>
             </a:fld>
@@ -2918,7 +3003,7 @@
     </p:spTree>
     <p:extLst>
       <p:ext uri="{BB962C8B-B14F-4D97-AF65-F5344CB8AC3E}">
-        <p14:creationId xmlns:p14="http://schemas.microsoft.com/office/powerpoint/2010/main" val="2581584113"/>
+        <p14:creationId xmlns:p14="http://schemas.microsoft.com/office/powerpoint/2010/main" val="497760881"/>
       </p:ext>
     </p:extLst>
   </p:cSld>
@@ -2991,7 +3076,7 @@
           <a:bodyPr/>
           <a:lstStyle/>
           <a:p>
-            <a:fld id="{0FCF8F27-596B-4576-8FC0-45CAC942679A}" type="slidenum">
+            <a:fld id="{AEAAFB2C-D2FA-4015-8580-9D15DAF0315E}" type="slidenum">
               <a:rPr lang="en-US" smtClean="0"/>
               <a:t>6</a:t>
             </a:fld>
@@ -3002,7 +3087,7 @@
     </p:spTree>
     <p:extLst>
       <p:ext uri="{BB962C8B-B14F-4D97-AF65-F5344CB8AC3E}">
-        <p14:creationId xmlns:p14="http://schemas.microsoft.com/office/powerpoint/2010/main" val="3859399784"/>
+        <p14:creationId xmlns:p14="http://schemas.microsoft.com/office/powerpoint/2010/main" val="1419050967"/>
       </p:ext>
     </p:extLst>
   </p:cSld>
@@ -3075,7 +3160,7 @@
           <a:bodyPr/>
           <a:lstStyle/>
           <a:p>
-            <a:fld id="{0FCF8F27-596B-4576-8FC0-45CAC942679A}" type="slidenum">
+            <a:fld id="{AEAAFB2C-D2FA-4015-8580-9D15DAF0315E}" type="slidenum">
               <a:rPr lang="en-US" smtClean="0"/>
               <a:t>7</a:t>
             </a:fld>
@@ -3086,7 +3171,7 @@
     </p:spTree>
     <p:extLst>
       <p:ext uri="{BB962C8B-B14F-4D97-AF65-F5344CB8AC3E}">
-        <p14:creationId xmlns:p14="http://schemas.microsoft.com/office/powerpoint/2010/main" val="286131378"/>
+        <p14:creationId xmlns:p14="http://schemas.microsoft.com/office/powerpoint/2010/main" val="2515424028"/>
       </p:ext>
     </p:extLst>
   </p:cSld>
@@ -3159,7 +3244,7 @@
           <a:bodyPr/>
           <a:lstStyle/>
           <a:p>
-            <a:fld id="{0FCF8F27-596B-4576-8FC0-45CAC942679A}" type="slidenum">
+            <a:fld id="{AEAAFB2C-D2FA-4015-8580-9D15DAF0315E}" type="slidenum">
               <a:rPr lang="en-US" smtClean="0"/>
               <a:t>8</a:t>
             </a:fld>
@@ -3170,7 +3255,7 @@
     </p:spTree>
     <p:extLst>
       <p:ext uri="{BB962C8B-B14F-4D97-AF65-F5344CB8AC3E}">
-        <p14:creationId xmlns:p14="http://schemas.microsoft.com/office/powerpoint/2010/main" val="491605125"/>
+        <p14:creationId xmlns:p14="http://schemas.microsoft.com/office/powerpoint/2010/main" val="3115289447"/>
       </p:ext>
     </p:extLst>
   </p:cSld>
@@ -3243,7 +3328,7 @@
           <a:bodyPr/>
           <a:lstStyle/>
           <a:p>
-            <a:fld id="{0FCF8F27-596B-4576-8FC0-45CAC942679A}" type="slidenum">
+            <a:fld id="{AEAAFB2C-D2FA-4015-8580-9D15DAF0315E}" type="slidenum">
               <a:rPr lang="en-US" smtClean="0"/>
               <a:t>9</a:t>
             </a:fld>
@@ -3254,7 +3339,7 @@
     </p:spTree>
     <p:extLst>
       <p:ext uri="{BB962C8B-B14F-4D97-AF65-F5344CB8AC3E}">
-        <p14:creationId xmlns:p14="http://schemas.microsoft.com/office/powerpoint/2010/main" val="2011995761"/>
+        <p14:creationId xmlns:p14="http://schemas.microsoft.com/office/powerpoint/2010/main" val="1238009431"/>
       </p:ext>
     </p:extLst>
   </p:cSld>
@@ -3393,7 +3478,7 @@
           <a:bodyPr/>
           <a:lstStyle/>
           <a:p>
-            <a:fld id="{849B24E3-999F-40F6-8FB6-D9607025B0F9}" type="datetimeFigureOut">
+            <a:fld id="{1E176B3A-C0B4-498B-9183-EF90B198E818}" type="datetimeFigureOut">
               <a:rPr lang="en-US" smtClean="0"/>
               <a:t>10/29/2026</a:t>
             </a:fld>
@@ -3435,7 +3520,7 @@
           <a:bodyPr/>
           <a:lstStyle/>
           <a:p>
-            <a:fld id="{B21E52B1-910D-4EFF-984C-F1ABB142E7D0}" type="slidenum">
+            <a:fld id="{57F09B0C-C3BD-478A-AC2E-153ED73DC987}" type="slidenum">
               <a:rPr lang="en-US" smtClean="0"/>
               <a:t>‹#›</a:t>
             </a:fld>
@@ -3446,7 +3531,7 @@
     </p:spTree>
     <p:extLst>
       <p:ext uri="{BB962C8B-B14F-4D97-AF65-F5344CB8AC3E}">
-        <p14:creationId xmlns:p14="http://schemas.microsoft.com/office/powerpoint/2010/main" val="754042954"/>
+        <p14:creationId xmlns:p14="http://schemas.microsoft.com/office/powerpoint/2010/main" val="3409170877"/>
       </p:ext>
     </p:extLst>
   </p:cSld>
@@ -3563,7 +3648,7 @@
           <a:bodyPr/>
           <a:lstStyle/>
           <a:p>
-            <a:fld id="{849B24E3-999F-40F6-8FB6-D9607025B0F9}" type="datetimeFigureOut">
+            <a:fld id="{1E176B3A-C0B4-498B-9183-EF90B198E818}" type="datetimeFigureOut">
               <a:rPr lang="en-US" smtClean="0"/>
               <a:t>10/29/2026</a:t>
             </a:fld>
@@ -3605,7 +3690,7 @@
           <a:bodyPr/>
           <a:lstStyle/>
           <a:p>
-            <a:fld id="{B21E52B1-910D-4EFF-984C-F1ABB142E7D0}" type="slidenum">
+            <a:fld id="{57F09B0C-C3BD-478A-AC2E-153ED73DC987}" type="slidenum">
               <a:rPr lang="en-US" smtClean="0"/>
               <a:t>‹#›</a:t>
             </a:fld>
@@ -3616,7 +3701,7 @@
     </p:spTree>
     <p:extLst>
       <p:ext uri="{BB962C8B-B14F-4D97-AF65-F5344CB8AC3E}">
-        <p14:creationId xmlns:p14="http://schemas.microsoft.com/office/powerpoint/2010/main" val="2421962577"/>
+        <p14:creationId xmlns:p14="http://schemas.microsoft.com/office/powerpoint/2010/main" val="2267476401"/>
       </p:ext>
     </p:extLst>
   </p:cSld>
@@ -3743,7 +3828,7 @@
           <a:bodyPr/>
           <a:lstStyle/>
           <a:p>
-            <a:fld id="{849B24E3-999F-40F6-8FB6-D9607025B0F9}" type="datetimeFigureOut">
+            <a:fld id="{1E176B3A-C0B4-498B-9183-EF90B198E818}" type="datetimeFigureOut">
               <a:rPr lang="en-US" smtClean="0"/>
               <a:t>10/29/2026</a:t>
             </a:fld>
@@ -3785,7 +3870,7 @@
           <a:bodyPr/>
           <a:lstStyle/>
           <a:p>
-            <a:fld id="{B21E52B1-910D-4EFF-984C-F1ABB142E7D0}" type="slidenum">
+            <a:fld id="{57F09B0C-C3BD-478A-AC2E-153ED73DC987}" type="slidenum">
               <a:rPr lang="en-US" smtClean="0"/>
               <a:t>‹#›</a:t>
             </a:fld>
@@ -3796,7 +3881,7 @@
     </p:spTree>
     <p:extLst>
       <p:ext uri="{BB962C8B-B14F-4D97-AF65-F5344CB8AC3E}">
-        <p14:creationId xmlns:p14="http://schemas.microsoft.com/office/powerpoint/2010/main" val="1297772030"/>
+        <p14:creationId xmlns:p14="http://schemas.microsoft.com/office/powerpoint/2010/main" val="1232735830"/>
       </p:ext>
     </p:extLst>
   </p:cSld>
@@ -3913,7 +3998,7 @@
           <a:bodyPr/>
           <a:lstStyle/>
           <a:p>
-            <a:fld id="{849B24E3-999F-40F6-8FB6-D9607025B0F9}" type="datetimeFigureOut">
+            <a:fld id="{1E176B3A-C0B4-498B-9183-EF90B198E818}" type="datetimeFigureOut">
               <a:rPr lang="en-US" smtClean="0"/>
               <a:t>10/29/2026</a:t>
             </a:fld>
@@ -3955,7 +4040,7 @@
           <a:bodyPr/>
           <a:lstStyle/>
           <a:p>
-            <a:fld id="{B21E52B1-910D-4EFF-984C-F1ABB142E7D0}" type="slidenum">
+            <a:fld id="{57F09B0C-C3BD-478A-AC2E-153ED73DC987}" type="slidenum">
               <a:rPr lang="en-US" smtClean="0"/>
               <a:t>‹#›</a:t>
             </a:fld>
@@ -3966,7 +4051,7 @@
     </p:spTree>
     <p:extLst>
       <p:ext uri="{BB962C8B-B14F-4D97-AF65-F5344CB8AC3E}">
-        <p14:creationId xmlns:p14="http://schemas.microsoft.com/office/powerpoint/2010/main" val="3954873672"/>
+        <p14:creationId xmlns:p14="http://schemas.microsoft.com/office/powerpoint/2010/main" val="2151179822"/>
       </p:ext>
     </p:extLst>
   </p:cSld>
@@ -4159,7 +4244,7 @@
           <a:bodyPr/>
           <a:lstStyle/>
           <a:p>
-            <a:fld id="{849B24E3-999F-40F6-8FB6-D9607025B0F9}" type="datetimeFigureOut">
+            <a:fld id="{1E176B3A-C0B4-498B-9183-EF90B198E818}" type="datetimeFigureOut">
               <a:rPr lang="en-US" smtClean="0"/>
               <a:t>10/29/2026</a:t>
             </a:fld>
@@ -4201,7 +4286,7 @@
           <a:bodyPr/>
           <a:lstStyle/>
           <a:p>
-            <a:fld id="{B21E52B1-910D-4EFF-984C-F1ABB142E7D0}" type="slidenum">
+            <a:fld id="{57F09B0C-C3BD-478A-AC2E-153ED73DC987}" type="slidenum">
               <a:rPr lang="en-US" smtClean="0"/>
               <a:t>‹#›</a:t>
             </a:fld>
@@ -4212,7 +4297,7 @@
     </p:spTree>
     <p:extLst>
       <p:ext uri="{BB962C8B-B14F-4D97-AF65-F5344CB8AC3E}">
-        <p14:creationId xmlns:p14="http://schemas.microsoft.com/office/powerpoint/2010/main" val="1889396306"/>
+        <p14:creationId xmlns:p14="http://schemas.microsoft.com/office/powerpoint/2010/main" val="1156932367"/>
       </p:ext>
     </p:extLst>
   </p:cSld>
@@ -4391,7 +4476,7 @@
           <a:bodyPr/>
           <a:lstStyle/>
           <a:p>
-            <a:fld id="{849B24E3-999F-40F6-8FB6-D9607025B0F9}" type="datetimeFigureOut">
+            <a:fld id="{1E176B3A-C0B4-498B-9183-EF90B198E818}" type="datetimeFigureOut">
               <a:rPr lang="en-US" smtClean="0"/>
               <a:t>10/29/2026</a:t>
             </a:fld>
@@ -4433,7 +4518,7 @@
           <a:bodyPr/>
           <a:lstStyle/>
           <a:p>
-            <a:fld id="{B21E52B1-910D-4EFF-984C-F1ABB142E7D0}" type="slidenum">
+            <a:fld id="{57F09B0C-C3BD-478A-AC2E-153ED73DC987}" type="slidenum">
               <a:rPr lang="en-US" smtClean="0"/>
               <a:t>‹#›</a:t>
             </a:fld>
@@ -4444,7 +4529,7 @@
     </p:spTree>
     <p:extLst>
       <p:ext uri="{BB962C8B-B14F-4D97-AF65-F5344CB8AC3E}">
-        <p14:creationId xmlns:p14="http://schemas.microsoft.com/office/powerpoint/2010/main" val="1513420721"/>
+        <p14:creationId xmlns:p14="http://schemas.microsoft.com/office/powerpoint/2010/main" val="175033713"/>
       </p:ext>
     </p:extLst>
   </p:cSld>
@@ -4758,7 +4843,7 @@
           <a:bodyPr/>
           <a:lstStyle/>
           <a:p>
-            <a:fld id="{849B24E3-999F-40F6-8FB6-D9607025B0F9}" type="datetimeFigureOut">
+            <a:fld id="{1E176B3A-C0B4-498B-9183-EF90B198E818}" type="datetimeFigureOut">
               <a:rPr lang="en-US" smtClean="0"/>
               <a:t>10/29/2026</a:t>
             </a:fld>
@@ -4800,7 +4885,7 @@
           <a:bodyPr/>
           <a:lstStyle/>
           <a:p>
-            <a:fld id="{B21E52B1-910D-4EFF-984C-F1ABB142E7D0}" type="slidenum">
+            <a:fld id="{57F09B0C-C3BD-478A-AC2E-153ED73DC987}" type="slidenum">
               <a:rPr lang="en-US" smtClean="0"/>
               <a:t>‹#›</a:t>
             </a:fld>
@@ -4811,7 +4896,7 @@
     </p:spTree>
     <p:extLst>
       <p:ext uri="{BB962C8B-B14F-4D97-AF65-F5344CB8AC3E}">
-        <p14:creationId xmlns:p14="http://schemas.microsoft.com/office/powerpoint/2010/main" val="3492322576"/>
+        <p14:creationId xmlns:p14="http://schemas.microsoft.com/office/powerpoint/2010/main" val="2656493976"/>
       </p:ext>
     </p:extLst>
   </p:cSld>
@@ -4876,7 +4961,7 @@
           <a:bodyPr/>
           <a:lstStyle/>
           <a:p>
-            <a:fld id="{849B24E3-999F-40F6-8FB6-D9607025B0F9}" type="datetimeFigureOut">
+            <a:fld id="{1E176B3A-C0B4-498B-9183-EF90B198E818}" type="datetimeFigureOut">
               <a:rPr lang="en-US" smtClean="0"/>
               <a:t>10/29/2026</a:t>
             </a:fld>
@@ -4918,7 +5003,7 @@
           <a:bodyPr/>
           <a:lstStyle/>
           <a:p>
-            <a:fld id="{B21E52B1-910D-4EFF-984C-F1ABB142E7D0}" type="slidenum">
+            <a:fld id="{57F09B0C-C3BD-478A-AC2E-153ED73DC987}" type="slidenum">
               <a:rPr lang="en-US" smtClean="0"/>
               <a:t>‹#›</a:t>
             </a:fld>
@@ -4929,7 +5014,7 @@
     </p:spTree>
     <p:extLst>
       <p:ext uri="{BB962C8B-B14F-4D97-AF65-F5344CB8AC3E}">
-        <p14:creationId xmlns:p14="http://schemas.microsoft.com/office/powerpoint/2010/main" val="155670477"/>
+        <p14:creationId xmlns:p14="http://schemas.microsoft.com/office/powerpoint/2010/main" val="1799651105"/>
       </p:ext>
     </p:extLst>
   </p:cSld>
@@ -4971,7 +5056,7 @@
           <a:bodyPr/>
           <a:lstStyle/>
           <a:p>
-            <a:fld id="{849B24E3-999F-40F6-8FB6-D9607025B0F9}" type="datetimeFigureOut">
+            <a:fld id="{1E176B3A-C0B4-498B-9183-EF90B198E818}" type="datetimeFigureOut">
               <a:rPr lang="en-US" smtClean="0"/>
               <a:t>10/29/2026</a:t>
             </a:fld>
@@ -5013,7 +5098,7 @@
           <a:bodyPr/>
           <a:lstStyle/>
           <a:p>
-            <a:fld id="{B21E52B1-910D-4EFF-984C-F1ABB142E7D0}" type="slidenum">
+            <a:fld id="{57F09B0C-C3BD-478A-AC2E-153ED73DC987}" type="slidenum">
               <a:rPr lang="en-US" smtClean="0"/>
               <a:t>‹#›</a:t>
             </a:fld>
@@ -5024,7 +5109,7 @@
     </p:spTree>
     <p:extLst>
       <p:ext uri="{BB962C8B-B14F-4D97-AF65-F5344CB8AC3E}">
-        <p14:creationId xmlns:p14="http://schemas.microsoft.com/office/powerpoint/2010/main" val="1427381592"/>
+        <p14:creationId xmlns:p14="http://schemas.microsoft.com/office/powerpoint/2010/main" val="371897373"/>
       </p:ext>
     </p:extLst>
   </p:cSld>
@@ -5248,7 +5333,7 @@
           <a:bodyPr/>
           <a:lstStyle/>
           <a:p>
-            <a:fld id="{849B24E3-999F-40F6-8FB6-D9607025B0F9}" type="datetimeFigureOut">
+            <a:fld id="{1E176B3A-C0B4-498B-9183-EF90B198E818}" type="datetimeFigureOut">
               <a:rPr lang="en-US" smtClean="0"/>
               <a:t>10/29/2026</a:t>
             </a:fld>
@@ -5290,7 +5375,7 @@
           <a:bodyPr/>
           <a:lstStyle/>
           <a:p>
-            <a:fld id="{B21E52B1-910D-4EFF-984C-F1ABB142E7D0}" type="slidenum">
+            <a:fld id="{57F09B0C-C3BD-478A-AC2E-153ED73DC987}" type="slidenum">
               <a:rPr lang="en-US" smtClean="0"/>
               <a:t>‹#›</a:t>
             </a:fld>
@@ -5301,7 +5386,7 @@
     </p:spTree>
     <p:extLst>
       <p:ext uri="{BB962C8B-B14F-4D97-AF65-F5344CB8AC3E}">
-        <p14:creationId xmlns:p14="http://schemas.microsoft.com/office/powerpoint/2010/main" val="528803551"/>
+        <p14:creationId xmlns:p14="http://schemas.microsoft.com/office/powerpoint/2010/main" val="2992586019"/>
       </p:ext>
     </p:extLst>
   </p:cSld>
@@ -5501,7 +5586,7 @@
           <a:bodyPr/>
           <a:lstStyle/>
           <a:p>
-            <a:fld id="{849B24E3-999F-40F6-8FB6-D9607025B0F9}" type="datetimeFigureOut">
+            <a:fld id="{1E176B3A-C0B4-498B-9183-EF90B198E818}" type="datetimeFigureOut">
               <a:rPr lang="en-US" smtClean="0"/>
               <a:t>10/29/2026</a:t>
             </a:fld>
@@ -5543,7 +5628,7 @@
           <a:bodyPr/>
           <a:lstStyle/>
           <a:p>
-            <a:fld id="{B21E52B1-910D-4EFF-984C-F1ABB142E7D0}" type="slidenum">
+            <a:fld id="{57F09B0C-C3BD-478A-AC2E-153ED73DC987}" type="slidenum">
               <a:rPr lang="en-US" smtClean="0"/>
               <a:t>‹#›</a:t>
             </a:fld>
@@ -5554,7 +5639,7 @@
     </p:spTree>
     <p:extLst>
       <p:ext uri="{BB962C8B-B14F-4D97-AF65-F5344CB8AC3E}">
-        <p14:creationId xmlns:p14="http://schemas.microsoft.com/office/powerpoint/2010/main" val="1258652461"/>
+        <p14:creationId xmlns:p14="http://schemas.microsoft.com/office/powerpoint/2010/main" val="1832607909"/>
       </p:ext>
     </p:extLst>
   </p:cSld>
@@ -5714,7 +5799,7 @@
             </a:lvl1pPr>
           </a:lstStyle>
           <a:p>
-            <a:fld id="{849B24E3-999F-40F6-8FB6-D9607025B0F9}" type="datetimeFigureOut">
+            <a:fld id="{1E176B3A-C0B4-498B-9183-EF90B198E818}" type="datetimeFigureOut">
               <a:rPr lang="en-US" smtClean="0"/>
               <a:t>10/29/2026</a:t>
             </a:fld>
@@ -5792,7 +5877,7 @@
             </a:lvl1pPr>
           </a:lstStyle>
           <a:p>
-            <a:fld id="{B21E52B1-910D-4EFF-984C-F1ABB142E7D0}" type="slidenum">
+            <a:fld id="{57F09B0C-C3BD-478A-AC2E-153ED73DC987}" type="slidenum">
               <a:rPr lang="en-US" smtClean="0"/>
               <a:t>‹#›</a:t>
             </a:fld>
@@ -5803,7 +5888,7 @@
     </p:spTree>
     <p:extLst>
       <p:ext uri="{BB962C8B-B14F-4D97-AF65-F5344CB8AC3E}">
-        <p14:creationId xmlns:p14="http://schemas.microsoft.com/office/powerpoint/2010/main" val="2458856845"/>
+        <p14:creationId xmlns:p14="http://schemas.microsoft.com/office/powerpoint/2010/main" val="1066443814"/>
       </p:ext>
     </p:extLst>
   </p:cSld>
@@ -6373,7 +6458,7 @@
     </p:spTree>
     <p:extLst>
       <p:ext uri="{BB962C8B-B14F-4D97-AF65-F5344CB8AC3E}">
-        <p14:creationId xmlns:p14="http://schemas.microsoft.com/office/powerpoint/2010/main" val="430569955"/>
+        <p14:creationId xmlns:p14="http://schemas.microsoft.com/office/powerpoint/2010/main" val="2988724163"/>
       </p:ext>
     </p:extLst>
   </p:cSld>
@@ -6641,7 +6726,7 @@
     </p:spTree>
     <p:extLst>
       <p:ext uri="{BB962C8B-B14F-4D97-AF65-F5344CB8AC3E}">
-        <p14:creationId xmlns:p14="http://schemas.microsoft.com/office/powerpoint/2010/main" val="557583931"/>
+        <p14:creationId xmlns:p14="http://schemas.microsoft.com/office/powerpoint/2010/main" val="1837252951"/>
       </p:ext>
     </p:extLst>
   </p:cSld>
@@ -6909,7 +6994,7 @@
     </p:spTree>
     <p:extLst>
       <p:ext uri="{BB962C8B-B14F-4D97-AF65-F5344CB8AC3E}">
-        <p14:creationId xmlns:p14="http://schemas.microsoft.com/office/powerpoint/2010/main" val="2438925543"/>
+        <p14:creationId xmlns:p14="http://schemas.microsoft.com/office/powerpoint/2010/main" val="2421540894"/>
       </p:ext>
     </p:extLst>
   </p:cSld>
@@ -7177,7 +7262,7 @@
     </p:spTree>
     <p:extLst>
       <p:ext uri="{BB962C8B-B14F-4D97-AF65-F5344CB8AC3E}">
-        <p14:creationId xmlns:p14="http://schemas.microsoft.com/office/powerpoint/2010/main" val="3717790571"/>
+        <p14:creationId xmlns:p14="http://schemas.microsoft.com/office/powerpoint/2010/main" val="1563163077"/>
       </p:ext>
     </p:extLst>
   </p:cSld>
@@ -7445,7 +7530,7 @@
     </p:spTree>
     <p:extLst>
       <p:ext uri="{BB962C8B-B14F-4D97-AF65-F5344CB8AC3E}">
-        <p14:creationId xmlns:p14="http://schemas.microsoft.com/office/powerpoint/2010/main" val="1961801509"/>
+        <p14:creationId xmlns:p14="http://schemas.microsoft.com/office/powerpoint/2010/main" val="2555313374"/>
       </p:ext>
     </p:extLst>
   </p:cSld>
@@ -7713,7 +7798,7 @@
     </p:spTree>
     <p:extLst>
       <p:ext uri="{BB962C8B-B14F-4D97-AF65-F5344CB8AC3E}">
-        <p14:creationId xmlns:p14="http://schemas.microsoft.com/office/powerpoint/2010/main" val="3469239612"/>
+        <p14:creationId xmlns:p14="http://schemas.microsoft.com/office/powerpoint/2010/main" val="2603611675"/>
       </p:ext>
     </p:extLst>
   </p:cSld>
@@ -7981,7 +8066,7 @@
     </p:spTree>
     <p:extLst>
       <p:ext uri="{BB962C8B-B14F-4D97-AF65-F5344CB8AC3E}">
-        <p14:creationId xmlns:p14="http://schemas.microsoft.com/office/powerpoint/2010/main" val="1271040037"/>
+        <p14:creationId xmlns:p14="http://schemas.microsoft.com/office/powerpoint/2010/main" val="1779697027"/>
       </p:ext>
     </p:extLst>
   </p:cSld>
@@ -8249,7 +8334,7 @@
     </p:spTree>
     <p:extLst>
       <p:ext uri="{BB962C8B-B14F-4D97-AF65-F5344CB8AC3E}">
-        <p14:creationId xmlns:p14="http://schemas.microsoft.com/office/powerpoint/2010/main" val="2201960841"/>
+        <p14:creationId xmlns:p14="http://schemas.microsoft.com/office/powerpoint/2010/main" val="353805230"/>
       </p:ext>
     </p:extLst>
   </p:cSld>
@@ -8517,7 +8602,7 @@
     </p:spTree>
     <p:extLst>
       <p:ext uri="{BB962C8B-B14F-4D97-AF65-F5344CB8AC3E}">
-        <p14:creationId xmlns:p14="http://schemas.microsoft.com/office/powerpoint/2010/main" val="2243089153"/>
+        <p14:creationId xmlns:p14="http://schemas.microsoft.com/office/powerpoint/2010/main" val="3741640387"/>
       </p:ext>
     </p:extLst>
   </p:cSld>
@@ -8785,7 +8870,7 @@
     </p:spTree>
     <p:extLst>
       <p:ext uri="{BB962C8B-B14F-4D97-AF65-F5344CB8AC3E}">
-        <p14:creationId xmlns:p14="http://schemas.microsoft.com/office/powerpoint/2010/main" val="769931337"/>
+        <p14:creationId xmlns:p14="http://schemas.microsoft.com/office/powerpoint/2010/main" val="4283291337"/>
       </p:ext>
     </p:extLst>
   </p:cSld>
@@ -9053,7 +9138,7 @@
     </p:spTree>
     <p:extLst>
       <p:ext uri="{BB962C8B-B14F-4D97-AF65-F5344CB8AC3E}">
-        <p14:creationId xmlns:p14="http://schemas.microsoft.com/office/powerpoint/2010/main" val="1850705672"/>
+        <p14:creationId xmlns:p14="http://schemas.microsoft.com/office/powerpoint/2010/main" val="941274722"/>
       </p:ext>
     </p:extLst>
   </p:cSld>
@@ -9321,7 +9406,7 @@
     </p:spTree>
     <p:extLst>
       <p:ext uri="{BB962C8B-B14F-4D97-AF65-F5344CB8AC3E}">
-        <p14:creationId xmlns:p14="http://schemas.microsoft.com/office/powerpoint/2010/main" val="3423667517"/>
+        <p14:creationId xmlns:p14="http://schemas.microsoft.com/office/powerpoint/2010/main" val="2762432518"/>
       </p:ext>
     </p:extLst>
   </p:cSld>
@@ -9589,7 +9674,7 @@
     </p:spTree>
     <p:extLst>
       <p:ext uri="{BB962C8B-B14F-4D97-AF65-F5344CB8AC3E}">
-        <p14:creationId xmlns:p14="http://schemas.microsoft.com/office/powerpoint/2010/main" val="4124692145"/>
+        <p14:creationId xmlns:p14="http://schemas.microsoft.com/office/powerpoint/2010/main" val="1431443444"/>
       </p:ext>
     </p:extLst>
   </p:cSld>
@@ -9857,7 +9942,7 @@
     </p:spTree>
     <p:extLst>
       <p:ext uri="{BB962C8B-B14F-4D97-AF65-F5344CB8AC3E}">
-        <p14:creationId xmlns:p14="http://schemas.microsoft.com/office/powerpoint/2010/main" val="1604872043"/>
+        <p14:creationId xmlns:p14="http://schemas.microsoft.com/office/powerpoint/2010/main" val="2010116258"/>
       </p:ext>
     </p:extLst>
   </p:cSld>
@@ -10125,7 +10210,7 @@
     </p:spTree>
     <p:extLst>
       <p:ext uri="{BB962C8B-B14F-4D97-AF65-F5344CB8AC3E}">
-        <p14:creationId xmlns:p14="http://schemas.microsoft.com/office/powerpoint/2010/main" val="3089251531"/>
+        <p14:creationId xmlns:p14="http://schemas.microsoft.com/office/powerpoint/2010/main" val="856091755"/>
       </p:ext>
     </p:extLst>
   </p:cSld>
@@ -10393,7 +10478,7 @@
     </p:spTree>
     <p:extLst>
       <p:ext uri="{BB962C8B-B14F-4D97-AF65-F5344CB8AC3E}">
-        <p14:creationId xmlns:p14="http://schemas.microsoft.com/office/powerpoint/2010/main" val="2265358328"/>
+        <p14:creationId xmlns:p14="http://schemas.microsoft.com/office/powerpoint/2010/main" val="749872858"/>
       </p:ext>
     </p:extLst>
   </p:cSld>
@@ -10661,7 +10746,7 @@
     </p:spTree>
     <p:extLst>
       <p:ext uri="{BB962C8B-B14F-4D97-AF65-F5344CB8AC3E}">
-        <p14:creationId xmlns:p14="http://schemas.microsoft.com/office/powerpoint/2010/main" val="3751833230"/>
+        <p14:creationId xmlns:p14="http://schemas.microsoft.com/office/powerpoint/2010/main" val="1080359432"/>
       </p:ext>
     </p:extLst>
   </p:cSld>
@@ -10929,7 +11014,7 @@
     </p:spTree>
     <p:extLst>
       <p:ext uri="{BB962C8B-B14F-4D97-AF65-F5344CB8AC3E}">
-        <p14:creationId xmlns:p14="http://schemas.microsoft.com/office/powerpoint/2010/main" val="1978199522"/>
+        <p14:creationId xmlns:p14="http://schemas.microsoft.com/office/powerpoint/2010/main" val="1247277213"/>
       </p:ext>
     </p:extLst>
   </p:cSld>
@@ -11197,7 +11282,7 @@
     </p:spTree>
     <p:extLst>
       <p:ext uri="{BB962C8B-B14F-4D97-AF65-F5344CB8AC3E}">
-        <p14:creationId xmlns:p14="http://schemas.microsoft.com/office/powerpoint/2010/main" val="1363148866"/>
+        <p14:creationId xmlns:p14="http://schemas.microsoft.com/office/powerpoint/2010/main" val="4048135641"/>
       </p:ext>
     </p:extLst>
   </p:cSld>
@@ -11465,7 +11550,7 @@
     </p:spTree>
     <p:extLst>
       <p:ext uri="{BB962C8B-B14F-4D97-AF65-F5344CB8AC3E}">
-        <p14:creationId xmlns:p14="http://schemas.microsoft.com/office/powerpoint/2010/main" val="2354178915"/>
+        <p14:creationId xmlns:p14="http://schemas.microsoft.com/office/powerpoint/2010/main" val="3054030448"/>
       </p:ext>
     </p:extLst>
   </p:cSld>
@@ -11733,7 +11818,7 @@
     </p:spTree>
     <p:extLst>
       <p:ext uri="{BB962C8B-B14F-4D97-AF65-F5344CB8AC3E}">
-        <p14:creationId xmlns:p14="http://schemas.microsoft.com/office/powerpoint/2010/main" val="564183132"/>
+        <p14:creationId xmlns:p14="http://schemas.microsoft.com/office/powerpoint/2010/main" val="1772990728"/>
       </p:ext>
     </p:extLst>
   </p:cSld>
@@ -12001,7 +12086,7 @@
     </p:spTree>
     <p:extLst>
       <p:ext uri="{BB962C8B-B14F-4D97-AF65-F5344CB8AC3E}">
-        <p14:creationId xmlns:p14="http://schemas.microsoft.com/office/powerpoint/2010/main" val="3327269552"/>
+        <p14:creationId xmlns:p14="http://schemas.microsoft.com/office/powerpoint/2010/main" val="2975102409"/>
       </p:ext>
     </p:extLst>
   </p:cSld>
@@ -12269,7 +12354,7 @@
     </p:spTree>
     <p:extLst>
       <p:ext uri="{BB962C8B-B14F-4D97-AF65-F5344CB8AC3E}">
-        <p14:creationId xmlns:p14="http://schemas.microsoft.com/office/powerpoint/2010/main" val="3778720583"/>
+        <p14:creationId xmlns:p14="http://schemas.microsoft.com/office/powerpoint/2010/main" val="2217117112"/>
       </p:ext>
     </p:extLst>
   </p:cSld>
@@ -12537,7 +12622,7 @@
     </p:spTree>
     <p:extLst>
       <p:ext uri="{BB962C8B-B14F-4D97-AF65-F5344CB8AC3E}">
-        <p14:creationId xmlns:p14="http://schemas.microsoft.com/office/powerpoint/2010/main" val="4007215041"/>
+        <p14:creationId xmlns:p14="http://schemas.microsoft.com/office/powerpoint/2010/main" val="1625007015"/>
       </p:ext>
     </p:extLst>
   </p:cSld>
@@ -12805,7 +12890,7 @@
     </p:spTree>
     <p:extLst>
       <p:ext uri="{BB962C8B-B14F-4D97-AF65-F5344CB8AC3E}">
-        <p14:creationId xmlns:p14="http://schemas.microsoft.com/office/powerpoint/2010/main" val="2252512617"/>
+        <p14:creationId xmlns:p14="http://schemas.microsoft.com/office/powerpoint/2010/main" val="2930436087"/>
       </p:ext>
     </p:extLst>
   </p:cSld>
@@ -13073,7 +13158,7 @@
     </p:spTree>
     <p:extLst>
       <p:ext uri="{BB962C8B-B14F-4D97-AF65-F5344CB8AC3E}">
-        <p14:creationId xmlns:p14="http://schemas.microsoft.com/office/powerpoint/2010/main" val="1233752198"/>
+        <p14:creationId xmlns:p14="http://schemas.microsoft.com/office/powerpoint/2010/main" val="4042458135"/>
       </p:ext>
     </p:extLst>
   </p:cSld>
@@ -13217,7 +13302,7 @@
                 </a:solidFill>
                 <a:latin typeface="Segoe UI" panose="020B0502040204020203" pitchFamily="34" charset="0"/>
               </a:rPr>
-              <a:t>Le plan suivant ne détecte aucun changement. Estimation : 0,16 USD/h ; démonstration courte et nettoyage approuvé des volumes puis du cluster.</a:t>
+              <a:t>Le plan suivant ne détecte aucun changement. Estimation en activité : 0,16 USD/h ; les volumes puis le cluster ont été supprimés après accord.</a:t>
             </a:r>
             <a:endParaRPr lang="en-US" sz="1600">
               <a:solidFill>
@@ -13341,7 +13426,275 @@
     </p:spTree>
     <p:extLst>
       <p:ext uri="{BB962C8B-B14F-4D97-AF65-F5344CB8AC3E}">
-        <p14:creationId xmlns:p14="http://schemas.microsoft.com/office/powerpoint/2010/main" val="3754437182"/>
+        <p14:creationId xmlns:p14="http://schemas.microsoft.com/office/powerpoint/2010/main" val="780057793"/>
+      </p:ext>
+    </p:extLst>
+  </p:cSld>
+  <p:clrMapOvr>
+    <a:masterClrMapping/>
+  </p:clrMapOvr>
+</p:sld>
+</file>
+
+<file path=ppt/slides/slide34.xml><?xml version="1.0" encoding="utf-8"?>
+<p:sld xmlns:a="http://schemas.openxmlformats.org/drawingml/2006/main" xmlns:r="http://schemas.openxmlformats.org/officeDocument/2006/relationships" xmlns:p="http://schemas.openxmlformats.org/presentationml/2006/main">
+  <p:cSld>
+    <p:bg>
+      <p:bgPr>
+        <a:solidFill>
+          <a:srgbClr val="0F272A"/>
+        </a:solidFill>
+        <a:effectLst/>
+      </p:bgPr>
+    </p:bg>
+    <p:spTree>
+      <p:nvGrpSpPr>
+        <p:cNvPr id="1" name=""/>
+        <p:cNvGrpSpPr/>
+        <p:nvPr/>
+      </p:nvGrpSpPr>
+      <p:grpSpPr>
+        <a:xfrm>
+          <a:off x="0" y="0"/>
+          <a:ext cx="0" cy="0"/>
+          <a:chOff x="0" y="0"/>
+          <a:chExt cx="0" cy="0"/>
+        </a:xfrm>
+      </p:grpSpPr>
+      <p:sp>
+        <p:nvSpPr>
+          <p:cNvPr id="2" name="TextBox 1"/>
+          <p:cNvSpPr txBox="1"/>
+          <p:nvPr/>
+        </p:nvSpPr>
+        <p:spPr>
+          <a:xfrm>
+            <a:off x="381000" y="152400"/>
+            <a:ext cx="10795000" cy="261610"/>
+          </a:xfrm>
+          <a:prstGeom prst="rect">
+            <a:avLst/>
+          </a:prstGeom>
+          <a:noFill/>
+        </p:spPr>
+        <p:txBody>
+          <a:bodyPr vert="horz" rtlCol="0">
+            <a:spAutoFit/>
+          </a:bodyPr>
+          <a:lstStyle/>
+          <a:p>
+            <a:r>
+              <a:rPr lang="en-US" sz="1100" smtClean="0">
+                <a:solidFill>
+                  <a:srgbClr val="5EEAD4"/>
+                </a:solidFill>
+                <a:latin typeface="Segoe UI" panose="020B0502040204020203" pitchFamily="34" charset="0"/>
+              </a:rPr>
+              <a:t>EVENTSPROJECT / MODULE TACHE</a:t>
+            </a:r>
+            <a:endParaRPr lang="en-US" sz="1100">
+              <a:solidFill>
+                <a:srgbClr val="5EEAD4"/>
+              </a:solidFill>
+              <a:latin typeface="Segoe UI" panose="020B0502040204020203" pitchFamily="34" charset="0"/>
+            </a:endParaRPr>
+          </a:p>
+        </p:txBody>
+      </p:sp>
+      <p:sp>
+        <p:nvSpPr>
+          <p:cNvPr id="3" name="TextBox 2"/>
+          <p:cNvSpPr txBox="1"/>
+          <p:nvPr/>
+        </p:nvSpPr>
+        <p:spPr>
+          <a:xfrm>
+            <a:off x="381000" y="533400"/>
+            <a:ext cx="11430000" cy="523220"/>
+          </a:xfrm>
+          <a:prstGeom prst="rect">
+            <a:avLst/>
+          </a:prstGeom>
+          <a:noFill/>
+        </p:spPr>
+        <p:txBody>
+          <a:bodyPr vert="horz" rtlCol="0">
+            <a:spAutoFit/>
+          </a:bodyPr>
+          <a:lstStyle/>
+          <a:p>
+            <a:r>
+              <a:rPr lang="fr-FR" sz="2800" smtClean="0">
+                <a:solidFill>
+                  <a:srgbClr val="FFFFFF"/>
+                </a:solidFill>
+                <a:latin typeface="Segoe UI" panose="020B0502040204020203" pitchFamily="34" charset="0"/>
+              </a:rPr>
+              <a:t>Terminer le cycle de vie AWS</a:t>
+            </a:r>
+            <a:endParaRPr lang="en-US" sz="2800">
+              <a:solidFill>
+                <a:srgbClr val="FFFFFF"/>
+              </a:solidFill>
+              <a:latin typeface="Segoe UI" panose="020B0502040204020203" pitchFamily="34" charset="0"/>
+            </a:endParaRPr>
+          </a:p>
+        </p:txBody>
+      </p:sp>
+      <p:sp>
+        <p:nvSpPr>
+          <p:cNvPr id="4" name="TextBox 3"/>
+          <p:cNvSpPr txBox="1"/>
+          <p:nvPr/>
+        </p:nvSpPr>
+        <p:spPr>
+          <a:xfrm>
+            <a:off x="381000" y="1244600"/>
+            <a:ext cx="11430000" cy="584775"/>
+          </a:xfrm>
+          <a:prstGeom prst="rect">
+            <a:avLst/>
+          </a:prstGeom>
+          <a:noFill/>
+        </p:spPr>
+        <p:txBody>
+          <a:bodyPr vert="horz" rtlCol="0">
+            <a:spAutoFit/>
+          </a:bodyPr>
+          <a:lstStyle/>
+          <a:p>
+            <a:r>
+              <a:rPr lang="fr-FR" sz="1600" smtClean="0">
+                <a:solidFill>
+                  <a:srgbClr val="E1E1E1"/>
+                </a:solidFill>
+                <a:latin typeface="Segoe UI" panose="020B0502040204020203" pitchFamily="34" charset="0"/>
+              </a:rPr>
+              <a:t>Nettoyage approuvé et vérifié : cluster supprimé, worker terminé, quatre volumes EBS absents ; captures et livrables conservés, kind toujours disponible.</a:t>
+            </a:r>
+            <a:endParaRPr lang="en-US" sz="1600">
+              <a:solidFill>
+                <a:srgbClr val="E1E1E1"/>
+              </a:solidFill>
+              <a:latin typeface="Segoe UI" panose="020B0502040204020203" pitchFamily="34" charset="0"/>
+            </a:endParaRPr>
+          </a:p>
+        </p:txBody>
+      </p:sp>
+      <p:pic>
+        <p:nvPicPr>
+          <p:cNvPr id="5" name="Picture 4"/>
+          <p:cNvPicPr>
+            <a:picLocks noChangeAspect="1"/>
+          </p:cNvPicPr>
+          <p:nvPr/>
+        </p:nvPicPr>
+        <p:blipFill>
+          <a:blip r:embed="rId3">
+            <a:extLst>
+              <a:ext uri="{28A0092B-C50C-407E-A947-70E740481C1C}">
+                <a14:useLocalDpi xmlns:a14="http://schemas.microsoft.com/office/drawing/2010/main" val="0"/>
+              </a:ext>
+            </a:extLst>
+          </a:blip>
+          <a:stretch>
+            <a:fillRect/>
+          </a:stretch>
+        </p:blipFill>
+        <p:spPr>
+          <a:xfrm>
+            <a:off x="1953054" y="1981200"/>
+            <a:ext cx="8285892" cy="4318000"/>
+          </a:xfrm>
+          <a:prstGeom prst="rect">
+            <a:avLst/>
+          </a:prstGeom>
+        </p:spPr>
+      </p:pic>
+      <p:sp>
+        <p:nvSpPr>
+          <p:cNvPr id="6" name="TextBox 5"/>
+          <p:cNvSpPr txBox="1"/>
+          <p:nvPr/>
+        </p:nvSpPr>
+        <p:spPr>
+          <a:xfrm>
+            <a:off x="381000" y="6400800"/>
+            <a:ext cx="10795000" cy="230832"/>
+          </a:xfrm>
+          <a:prstGeom prst="rect">
+            <a:avLst/>
+          </a:prstGeom>
+          <a:noFill/>
+        </p:spPr>
+        <p:txBody>
+          <a:bodyPr vert="horz" rtlCol="0">
+            <a:spAutoFit/>
+          </a:bodyPr>
+          <a:lstStyle/>
+          <a:p>
+            <a:r>
+              <a:rPr lang="en-US" sz="900" smtClean="0">
+                <a:solidFill>
+                  <a:srgbClr val="5EEAD4"/>
+                </a:solidFill>
+                <a:latin typeface="Segoe UI" panose="020B0502040204020203" pitchFamily="34" charset="0"/>
+              </a:rPr>
+              <a:t>Preuve : 14-aws-eks/cleanup-verification.png</a:t>
+            </a:r>
+            <a:endParaRPr lang="en-US" sz="900">
+              <a:solidFill>
+                <a:srgbClr val="5EEAD4"/>
+              </a:solidFill>
+              <a:latin typeface="Segoe UI" panose="020B0502040204020203" pitchFamily="34" charset="0"/>
+            </a:endParaRPr>
+          </a:p>
+        </p:txBody>
+      </p:sp>
+      <p:sp>
+        <p:nvSpPr>
+          <p:cNvPr id="7" name="TextBox 6"/>
+          <p:cNvSpPr txBox="1"/>
+          <p:nvPr/>
+        </p:nvSpPr>
+        <p:spPr>
+          <a:xfrm>
+            <a:off x="11582400" y="6438900"/>
+            <a:ext cx="381000" cy="246221"/>
+          </a:xfrm>
+          <a:prstGeom prst="rect">
+            <a:avLst/>
+          </a:prstGeom>
+          <a:noFill/>
+        </p:spPr>
+        <p:txBody>
+          <a:bodyPr vert="horz" rtlCol="0">
+            <a:spAutoFit/>
+          </a:bodyPr>
+          <a:lstStyle/>
+          <a:p>
+            <a:r>
+              <a:rPr lang="en-US" sz="1000" smtClean="0">
+                <a:solidFill>
+                  <a:srgbClr val="E1E1E1"/>
+                </a:solidFill>
+                <a:latin typeface="Segoe UI" panose="020B0502040204020203" pitchFamily="34" charset="0"/>
+              </a:rPr>
+              <a:t>34</a:t>
+            </a:r>
+            <a:endParaRPr lang="en-US" sz="1000">
+              <a:solidFill>
+                <a:srgbClr val="E1E1E1"/>
+              </a:solidFill>
+              <a:latin typeface="Segoe UI" panose="020B0502040204020203" pitchFamily="34" charset="0"/>
+            </a:endParaRPr>
+          </a:p>
+        </p:txBody>
+      </p:sp>
+    </p:spTree>
+    <p:extLst>
+      <p:ext uri="{BB962C8B-B14F-4D97-AF65-F5344CB8AC3E}">
+        <p14:creationId xmlns:p14="http://schemas.microsoft.com/office/powerpoint/2010/main" val="1413229055"/>
       </p:ext>
     </p:extLst>
   </p:cSld>
@@ -13609,7 +13962,7 @@
     </p:spTree>
     <p:extLst>
       <p:ext uri="{BB962C8B-B14F-4D97-AF65-F5344CB8AC3E}">
-        <p14:creationId xmlns:p14="http://schemas.microsoft.com/office/powerpoint/2010/main" val="2522153908"/>
+        <p14:creationId xmlns:p14="http://schemas.microsoft.com/office/powerpoint/2010/main" val="4196291056"/>
       </p:ext>
     </p:extLst>
   </p:cSld>
@@ -13877,7 +14230,7 @@
     </p:spTree>
     <p:extLst>
       <p:ext uri="{BB962C8B-B14F-4D97-AF65-F5344CB8AC3E}">
-        <p14:creationId xmlns:p14="http://schemas.microsoft.com/office/powerpoint/2010/main" val="2984366812"/>
+        <p14:creationId xmlns:p14="http://schemas.microsoft.com/office/powerpoint/2010/main" val="2457479238"/>
       </p:ext>
     </p:extLst>
   </p:cSld>
@@ -14145,7 +14498,7 @@
     </p:spTree>
     <p:extLst>
       <p:ext uri="{BB962C8B-B14F-4D97-AF65-F5344CB8AC3E}">
-        <p14:creationId xmlns:p14="http://schemas.microsoft.com/office/powerpoint/2010/main" val="1204185423"/>
+        <p14:creationId xmlns:p14="http://schemas.microsoft.com/office/powerpoint/2010/main" val="2197942124"/>
       </p:ext>
     </p:extLst>
   </p:cSld>
@@ -14413,7 +14766,7 @@
     </p:spTree>
     <p:extLst>
       <p:ext uri="{BB962C8B-B14F-4D97-AF65-F5344CB8AC3E}">
-        <p14:creationId xmlns:p14="http://schemas.microsoft.com/office/powerpoint/2010/main" val="1806719793"/>
+        <p14:creationId xmlns:p14="http://schemas.microsoft.com/office/powerpoint/2010/main" val="1091204846"/>
       </p:ext>
     </p:extLst>
   </p:cSld>
@@ -14681,7 +15034,7 @@
     </p:spTree>
     <p:extLst>
       <p:ext uri="{BB962C8B-B14F-4D97-AF65-F5344CB8AC3E}">
-        <p14:creationId xmlns:p14="http://schemas.microsoft.com/office/powerpoint/2010/main" val="3173672591"/>
+        <p14:creationId xmlns:p14="http://schemas.microsoft.com/office/powerpoint/2010/main" val="1891762401"/>
       </p:ext>
     </p:extLst>
   </p:cSld>
@@ -14949,7 +15302,7 @@
     </p:spTree>
     <p:extLst>
       <p:ext uri="{BB962C8B-B14F-4D97-AF65-F5344CB8AC3E}">
-        <p14:creationId xmlns:p14="http://schemas.microsoft.com/office/powerpoint/2010/main" val="126185293"/>
+        <p14:creationId xmlns:p14="http://schemas.microsoft.com/office/powerpoint/2010/main" val="2404483940"/>
       </p:ext>
     </p:extLst>
   </p:cSld>

</xml_diff>